<commit_message>
style: reduce left padding by 80%, remove em dashes and clean student wording
</commit_message>
<xml_diff>
--- a/Heatwave_MiniProject_Presentation.pptx
+++ b/Heatwave_MiniProject_Presentation.pptx
@@ -3233,7 +3233,7 @@
               </a:defRPr>
             </a:pPr>
             <a:r>
-              <a:t>Academic Year 2026-27 • Semester III</a:t>
+              <a:t>Academic Year 2026-27 - Semester III</a:t>
             </a:r>
           </a:p>
           <a:p>
@@ -3297,7 +3297,7 @@
               </a:defRPr>
             </a:pPr>
             <a:r>
-              <a:t>1. Mohammad Palekar (16010125167)  •  2. Gaurav (16010125164)  •  3. Samarth (16010125161)</a:t>
+              <a:t>1. Mohammad Palekar (16010125167)  -  2. Gaurav (16010125164)  -  3. Samarth (16010125161)</a:t>
             </a:r>
           </a:p>
           <a:p>
@@ -4043,7 +4043,7 @@
               </a:defRPr>
             </a:pPr>
             <a:r>
-              <a:t>• Experiment 1 (HTML5 Core): </a:t>
+              <a:t>- Experiment 1 (HTML5 Core): </a:t>
             </a:r>
             <a:r>
               <a:rPr b="0">
@@ -4066,7 +4066,7 @@
               </a:defRPr>
             </a:pPr>
             <a:r>
-              <a:t>• Experiment 2 (CSS3 Layout &amp; Styling): </a:t>
+              <a:t>- Experiment 2 (CSS3 Layout &amp; Styling): </a:t>
             </a:r>
             <a:r>
               <a:rPr b="0">
@@ -4089,7 +4089,7 @@
               </a:defRPr>
             </a:pPr>
             <a:r>
-              <a:t>• Experiment 4 (JavaScript Form Validation): </a:t>
+              <a:t>- Experiment 4 (JavaScript Form Validation): </a:t>
             </a:r>
             <a:r>
               <a:rPr b="0">
@@ -4112,7 +4112,7 @@
               </a:defRPr>
             </a:pPr>
             <a:r>
-              <a:t>• Experiment 5 (JS Climate Logic &amp; Arrays): </a:t>
+              <a:t>- Experiment 5 (JS Climate Logic &amp; Arrays): </a:t>
             </a:r>
             <a:r>
               <a:rPr b="0">
@@ -4427,7 +4427,7 @@
               </a:defRPr>
             </a:pPr>
             <a:r>
-              <a:t>• Successful Integration: Integrated all curriculum concepts across Experiments 1 to 5 into an authentic, production-ready climate intelligence portal.</a:t>
+              <a:t>- Successful Integration: Integrated all curriculum concepts across Experiments 1 to 5 into an authentic, production-ready climate intelligence portal.</a:t>
             </a:r>
           </a:p>
           <a:p>
@@ -4442,7 +4442,7 @@
               </a:defRPr>
             </a:pPr>
             <a:r>
-              <a:t>• Zero Framework Overhead: Built entirely using pure HTML5, CSS3, and Vanilla JavaScript, ensuring instantaneous load times (&lt;0.2s) and 100% browser compatibility.</a:t>
+              <a:t>- Zero Framework Overhead: Built entirely using pure HTML5, CSS3, and Vanilla JavaScript, ensuring instantaneous load times (&lt;0.2s) and 100% browser compatibility.</a:t>
             </a:r>
           </a:p>
           <a:p>
@@ -4457,7 +4457,7 @@
               </a:defRPr>
             </a:pPr>
             <a:r>
-              <a:t>• User-Centric &amp; Accessible: Clean, intuitive UI designed for ease of use by meteorologists, disaster officers, and common citizens during severe heatwave emergencies.</a:t>
+              <a:t>- User-Centric &amp; Accessible: Clean, intuitive UI designed for ease of use by meteorologists, disaster officers, and common citizens during severe heatwave emergencies.</a:t>
             </a:r>
           </a:p>
           <a:p>
@@ -4472,7 +4472,7 @@
               </a:defRPr>
             </a:pPr>
             <a:r>
-              <a:t>• Team Cohesion: Collaborative execution with clear separation of duties between Mohammad, Gaurav, and Samarth.</a:t>
+              <a:t>- Team Cohesion: Collaborative execution with clear separation of duties between Mohammad, Gaurav, and Samarth.</a:t>
             </a:r>
           </a:p>
         </p:txBody>
@@ -4570,7 +4570,7 @@
               </a:defRPr>
             </a:pPr>
             <a:r>
-              <a:t>• Real-Time IoT API Integration: Connect to live RESTful APIs and WebSocket feeds from municipal Automatic Weather Stations (AWS).</a:t>
+              <a:t>- Real-Time IoT API Integration: Connect to live RESTful APIs and WebSocket feeds from municipal Automatic Weather Stations (AWS).</a:t>
             </a:r>
           </a:p>
           <a:p>
@@ -4585,7 +4585,7 @@
               </a:defRPr>
             </a:pPr>
             <a:r>
-              <a:t>• Geospatial GIS Mapping: Upgrade static image maps to dynamic Leaflet.js or OpenLayers interactive heatmaps with GIS polygon layers.</a:t>
+              <a:t>- Geospatial GIS Mapping: Upgrade static image maps to dynamic Leaflet.js or OpenLayers interactive heatmaps with GIS polygon layers.</a:t>
             </a:r>
           </a:p>
           <a:p>
@@ -4600,7 +4600,7 @@
               </a:defRPr>
             </a:pPr>
             <a:r>
-              <a:t>• Push Notification Gateway: Implement Web Push API and SMS Twilio integration for automated real-time danger broadcasts.</a:t>
+              <a:t>- Push Notification Gateway: Implement Web Push API and SMS Twilio integration for automated real-time danger broadcasts.</a:t>
             </a:r>
           </a:p>
           <a:p>
@@ -4615,7 +4615,7 @@
               </a:defRPr>
             </a:pPr>
             <a:r>
-              <a:t>• Progressive Web App (PWA): Add Service Workers and offline caching so citizens can access emergency manuals even without internet.</a:t>
+              <a:t>- Progressive Web App (PWA): Add Service Workers and offline caching so citizens can access emergency manuals even without internet.</a:t>
             </a:r>
           </a:p>
         </p:txBody>
@@ -5108,7 +5108,7 @@
               </a:defRPr>
             </a:pPr>
             <a:r>
-              <a:t>• Submission on time before deadline (8th October).</a:t>
+              <a:t>- Submission on time before deadline (8th October).</a:t>
             </a:r>
           </a:p>
           <a:p>
@@ -5123,7 +5123,7 @@
               </a:defRPr>
             </a:pPr>
             <a:r>
-              <a:t>• Active participation of all 3 team members (Mohammad, Gaurav, Samarth).</a:t>
+              <a:t>- Active participation of all 3 team members (Mohammad, Gaurav, Samarth).</a:t>
             </a:r>
           </a:p>
           <a:p>
@@ -5138,7 +5138,7 @@
               </a:defRPr>
             </a:pPr>
             <a:r>
-              <a:t>• Seamless integration of HTML5, CSS3, and JS modules into one unified web portal.</a:t>
+              <a:t>- Seamless integration of HTML5, CSS3, and JS modules into one unified web portal.</a:t>
             </a:r>
           </a:p>
         </p:txBody>
@@ -5236,7 +5236,7 @@
               </a:defRPr>
             </a:pPr>
             <a:r>
-              <a:t>• Well-organized semantic content structure across 8 pages.</a:t>
+              <a:t>- Well-organized semantic content structure across 8 pages.</a:t>
             </a:r>
           </a:p>
           <a:p>
@@ -5251,7 +5251,7 @@
               </a:defRPr>
             </a:pPr>
             <a:r>
-              <a:t>• Proper GUI design properties: cohesive color scheme, CSS Box model, zebra tables, card layouts.</a:t>
+              <a:t>- Proper GUI design properties: cohesive color scheme, CSS Box model, zebra tables, card layouts.</a:t>
             </a:r>
           </a:p>
           <a:p>
@@ -5266,7 +5266,7 @@
               </a:defRPr>
             </a:pPr>
             <a:r>
-              <a:t>• Comprehensive documentation &amp; code compendium for each member.</a:t>
+              <a:t>- Comprehensive documentation &amp; code compendium for each member.</a:t>
             </a:r>
           </a:p>
         </p:txBody>
@@ -5364,7 +5364,7 @@
               </a:defRPr>
             </a:pPr>
             <a:r>
-              <a:t>• 100% Cross-browser compatible (tested on Chrome, Edge, Firefox).</a:t>
+              <a:t>- 100% Cross-browser compatible (tested on Chrome, Edge, Firefox).</a:t>
             </a:r>
           </a:p>
           <a:p>
@@ -5379,7 +5379,7 @@
               </a:defRPr>
             </a:pPr>
             <a:r>
-              <a:t>• Layout does not depend on fixed screen resolutions (responsive CSS flexbox &amp; media queries).</a:t>
+              <a:t>- Layout does not depend on fixed screen resolutions (responsive CSS flexbox &amp; media queries).</a:t>
             </a:r>
           </a:p>
           <a:p>
@@ -5394,7 +5394,7 @@
               </a:defRPr>
             </a:pPr>
             <a:r>
-              <a:t>• Accessible tags (&lt;abbr&gt;, alt texts, &lt;noscript&gt; fallback).</a:t>
+              <a:t>- Accessible tags (&lt;abbr&gt;, alt texts, &lt;noscript&gt; fallback).</a:t>
             </a:r>
           </a:p>
         </p:txBody>
@@ -5492,7 +5492,7 @@
               </a:defRPr>
             </a:pPr>
             <a:r>
-              <a:t>• Live demonstration of specific features: JS Regex validation, Climate Array Analytics, Object methods, Image Maps, Multimedia.</a:t>
+              <a:t>- Live demonstration of specific features: JS Regex validation, Climate Array Analytics, Object methods, Image Maps, Multimedia.</a:t>
             </a:r>
           </a:p>
           <a:p>
@@ -5507,7 +5507,7 @@
               </a:defRPr>
             </a:pPr>
             <a:r>
-              <a:t>• Clear presentation answering all technical and viva questions.</a:t>
+              <a:t>- Clear presentation answering all technical and viva questions.</a:t>
             </a:r>
           </a:p>
         </p:txBody>
@@ -5814,7 +5814,7 @@
               </a:defRPr>
             </a:pPr>
             <a:r>
-              <a:t>• Rising Global &amp; Regional Temperatures:</a:t>
+              <a:t>- Rising Global &amp; Regional Temperatures:</a:t>
             </a:r>
             <a:r>
               <a:rPr b="0">
@@ -5837,7 +5837,7 @@
               </a:defRPr>
             </a:pPr>
             <a:r>
-              <a:t>• Need for Multi-Stakeholder Intelligence:</a:t>
+              <a:t>- Need for Multi-Stakeholder Intelligence:</a:t>
             </a:r>
             <a:r>
               <a:rPr b="0">
@@ -5860,7 +5860,7 @@
               </a:defRPr>
             </a:pPr>
             <a:r>
-              <a:t>• Disaster Management Gaps:</a:t>
+              <a:t>- Disaster Management Gaps:</a:t>
             </a:r>
             <a:r>
               <a:rPr b="0">
@@ -5883,7 +5883,7 @@
               </a:defRPr>
             </a:pPr>
             <a:r>
-              <a:t>• Target Solution:</a:t>
+              <a:t>- Target Solution:</a:t>
             </a:r>
             <a:r>
               <a:rPr b="0">
@@ -6773,7 +6773,7 @@
               </a:defRPr>
             </a:pPr>
             <a:r>
-              <a:t>• HTML5 (HyperText Markup Language 5): </a:t>
+              <a:t>- HTML5 (HyperText Markup Language 5): </a:t>
             </a:r>
             <a:r>
               <a:rPr b="0">
@@ -6796,7 +6796,7 @@
               </a:defRPr>
             </a:pPr>
             <a:r>
-              <a:t>• CSS3 (Cascading Style Sheets 3): </a:t>
+              <a:t>- CSS3 (Cascading Style Sheets 3): </a:t>
             </a:r>
             <a:r>
               <a:rPr b="0">
@@ -6819,7 +6819,7 @@
               </a:defRPr>
             </a:pPr>
             <a:r>
-              <a:t>• Vanilla JavaScript (ES6+): </a:t>
+              <a:t>- Vanilla JavaScript (ES6+): </a:t>
             </a:r>
             <a:r>
               <a:rPr b="0">
@@ -6842,7 +6842,7 @@
               </a:defRPr>
             </a:pPr>
             <a:r>
-              <a:t>• Separation of Concerns &amp; Modularity: </a:t>
+              <a:t>- Separation of Concerns &amp; Modularity: </a:t>
             </a:r>
             <a:r>
               <a:rPr b="0">
@@ -7169,7 +7169,7 @@
               </a:defRPr>
             </a:pPr>
             <a:r>
-              <a:t>• Developed index.html, about.html, and media.html.</a:t>
+              <a:t>- Developed index.html, about.html, and media.html.</a:t>
             </a:r>
           </a:p>
           <a:p>
@@ -7184,7 +7184,7 @@
               </a:defRPr>
             </a:pPr>
             <a:r>
-              <a:t>• Designed multi-column meteorological tables (forecast.html) with rowspan and colspan.</a:t>
+              <a:t>- Designed multi-column meteorological tables (forecast.html) with rowspan and colspan.</a:t>
             </a:r>
           </a:p>
           <a:p>
@@ -7199,7 +7199,7 @@
               </a:defRPr>
             </a:pPr>
             <a:r>
-              <a:t>• Implemented client-side Image Maps (hotspot.html) with clickable sector coordinates.</a:t>
+              <a:t>- Implemented client-side Image Maps (hotspot.html) with clickable sector coordinates.</a:t>
             </a:r>
           </a:p>
           <a:p>
@@ -7214,7 +7214,7 @@
               </a:defRPr>
             </a:pPr>
             <a:r>
-              <a:t>• Embedded native HTML5 multimedia (&lt;video&gt;, &lt;audio&gt;, &lt;iframe&gt; radar feeds) and &lt;noscript&gt; fallbacks.</a:t>
+              <a:t>- Embedded native HTML5 multimedia (&lt;video&gt;, &lt;audio&gt;, &lt;iframe&gt; radar feeds) and &lt;noscript&gt; fallbacks.</a:t>
             </a:r>
           </a:p>
         </p:txBody>
@@ -7324,7 +7324,7 @@
               </a:defRPr>
             </a:pPr>
             <a:r>
-              <a:t>• Engineered global styling sheet (css/style.css) adhering to separation of concerns.</a:t>
+              <a:t>- Engineered global styling sheet (css/style.css) adhering to separation of concerns.</a:t>
             </a:r>
           </a:p>
           <a:p>
@@ -7339,7 +7339,7 @@
               </a:defRPr>
             </a:pPr>
             <a:r>
-              <a:t>• Built responsive layout grid with flexbox, card containers, and sticky navigation bar.</a:t>
+              <a:t>- Built responsive layout grid with flexbox, card containers, and sticky navigation bar.</a:t>
             </a:r>
           </a:p>
           <a:p>
@@ -7354,7 +7354,7 @@
               </a:defRPr>
             </a:pPr>
             <a:r>
-              <a:t>• Styled data tables with zebra-striping (tr:nth-child(even)) and hover feedback.</a:t>
+              <a:t>- Styled data tables with zebra-striping (tr:nth-child(even)) and hover feedback.</a:t>
             </a:r>
           </a:p>
           <a:p>
@@ -7369,7 +7369,7 @@
               </a:defRPr>
             </a:pPr>
             <a:r>
-              <a:t>• Crafted CSS @keyframes glowing alert box for Level 4 extreme heat advisory notices.</a:t>
+              <a:t>- Crafted CSS @keyframes glowing alert box for Level 4 extreme heat advisory notices.</a:t>
             </a:r>
           </a:p>
         </p:txBody>
@@ -7479,7 +7479,7 @@
               </a:defRPr>
             </a:pPr>
             <a:r>
-              <a:t>• Programmed js/validation.js utilizing Regular Expressions for 6 strict field constraints.</a:t>
+              <a:t>- Programmed js/validation.js utilizing Regular Expressions for 6 strict field constraints.</a:t>
             </a:r>
           </a:p>
           <a:p>
@@ -7494,7 +7494,7 @@
               </a:defRPr>
             </a:pPr>
             <a:r>
-              <a:t>• Created DOM error injection and real-time success alert banners on form submission.</a:t>
+              <a:t>- Created DOM error injection and real-time success alert banners on form submission.</a:t>
             </a:r>
           </a:p>
           <a:p>
@@ -7509,7 +7509,7 @@
               </a:defRPr>
             </a:pPr>
             <a:r>
-              <a:t>• Engineered js/analytics.js for multi-day temperature array analysis (min, max, average, threshold count).</a:t>
+              <a:t>- Engineered js/analytics.js for multi-day temperature array analysis (min, max, average, threshold count).</a:t>
             </a:r>
           </a:p>
           <a:p>
@@ -7524,7 +7524,7 @@
               </a:defRPr>
             </a:pPr>
             <a:r>
-              <a:t>• Implemented object-oriented climateData entity with member methods using this keyword.</a:t>
+              <a:t>- Implemented object-oriented climateData entity with member methods using this keyword.</a:t>
             </a:r>
           </a:p>
         </p:txBody>
@@ -7831,7 +7831,7 @@
               </a:defRPr>
             </a:pPr>
             <a:r>
-              <a:t>• Layer 1: Surveillance &amp; Landing (index.html, alerts.html): </a:t>
+              <a:t>- Layer 1: Surveillance &amp; Landing (index.html, alerts.html): </a:t>
             </a:r>
             <a:r>
               <a:rPr b="0">
@@ -7854,7 +7854,7 @@
               </a:defRPr>
             </a:pPr>
             <a:r>
-              <a:t>• Layer 2: Synoptic Data &amp; Mapping (forecast.html, hotspot.html): </a:t>
+              <a:t>- Layer 2: Synoptic Data &amp; Mapping (forecast.html, hotspot.html): </a:t>
             </a:r>
             <a:r>
               <a:rPr b="0">
@@ -7877,7 +7877,7 @@
               </a:defRPr>
             </a:pPr>
             <a:r>
-              <a:t>• Layer 3: Analytical Computational Engine (analysis.html): </a:t>
+              <a:t>- Layer 3: Analytical Computational Engine (analysis.html): </a:t>
             </a:r>
             <a:r>
               <a:rPr b="0">
@@ -7900,7 +7900,7 @@
               </a:defRPr>
             </a:pPr>
             <a:r>
-              <a:t>• Layer 4: Enrollment &amp; Public Notification (register.html): </a:t>
+              <a:t>- Layer 4: Enrollment &amp; Public Notification (register.html): </a:t>
             </a:r>
             <a:r>
               <a:rPr b="0">
@@ -7923,7 +7923,7 @@
               </a:defRPr>
             </a:pPr>
             <a:r>
-              <a:t>• Layer 5: Public Media &amp; Awareness (media.html): </a:t>
+              <a:t>- Layer 5: Public Media &amp; Awareness (media.html): </a:t>
             </a:r>
             <a:r>
               <a:rPr b="0">

</xml_diff>